<commit_message>
Fix typos in presentations
</commit_message>
<xml_diff>
--- a/instructors/L2-carbon-efficiency.pptx
+++ b/instructors/L2-carbon-efficiency.pptx
@@ -125,7 +125,7 @@
 <file path=ppt/revisionInfo.xml><?xml version="1.0" encoding="utf-8"?>
 <p1510:revInfo xmlns:a="http://schemas.openxmlformats.org/drawingml/2006/main" xmlns:r="http://schemas.openxmlformats.org/officeDocument/2006/relationships" xmlns:p1510="http://schemas.microsoft.com/office/powerpoint/2015/10/main">
   <p1510:revLst>
-    <p1510:client id="{BD4ECD50-1A96-A841-89F3-F97EDD04DE7B}" v="7" dt="2025-10-07T13:26:08.002"/>
+    <p1510:client id="{BB817E44-646B-D74A-9604-DA2226B713C6}" v="2" dt="2026-02-25T20:23:49.631"/>
   </p1510:revLst>
 </p1510:revInfo>
 </file>
@@ -135,165 +135,25 @@
   <pc:docChgLst>
     <pc:chgData name="Andrew Turner" userId="9b60647a-c825-4266-aafa-670849c64782" providerId="ADAL" clId="{292526B5-234E-5EAA-AFB8-0412B8CA4453}"/>
     <pc:docChg chg="addSld delSld modSld modMainMaster">
-      <pc:chgData name="Andrew Turner" userId="9b60647a-c825-4266-aafa-670849c64782" providerId="ADAL" clId="{292526B5-234E-5EAA-AFB8-0412B8CA4453}" dt="2025-10-07T13:26:08.002" v="19"/>
+      <pc:chgData name="Andrew Turner" userId="9b60647a-c825-4266-aafa-670849c64782" providerId="ADAL" clId="{292526B5-234E-5EAA-AFB8-0412B8CA4453}" dt="2026-02-25T20:23:15.009" v="24" actId="20577"/>
       <pc:docMkLst>
         <pc:docMk/>
       </pc:docMkLst>
-      <pc:sldChg chg="setBg">
-        <pc:chgData name="Andrew Turner" userId="9b60647a-c825-4266-aafa-670849c64782" providerId="ADAL" clId="{292526B5-234E-5EAA-AFB8-0412B8CA4453}" dt="2025-10-07T13:25:00.156" v="1"/>
+      <pc:sldChg chg="modSp mod">
+        <pc:chgData name="Andrew Turner" userId="9b60647a-c825-4266-aafa-670849c64782" providerId="ADAL" clId="{292526B5-234E-5EAA-AFB8-0412B8CA4453}" dt="2026-02-25T20:23:15.009" v="24" actId="20577"/>
         <pc:sldMkLst>
           <pc:docMk/>
-          <pc:sldMk cId="2097072578" sldId="256"/>
-        </pc:sldMkLst>
-      </pc:sldChg>
-      <pc:sldChg chg="modSp mod">
-        <pc:chgData name="Andrew Turner" userId="9b60647a-c825-4266-aafa-670849c64782" providerId="ADAL" clId="{292526B5-234E-5EAA-AFB8-0412B8CA4453}" dt="2025-10-07T13:25:14.190" v="4" actId="20577"/>
-        <pc:sldMkLst>
-          <pc:docMk/>
-          <pc:sldMk cId="3776241177" sldId="264"/>
+          <pc:sldMk cId="3766210556" sldId="259"/>
         </pc:sldMkLst>
         <pc:spChg chg="mod">
-          <ac:chgData name="Andrew Turner" userId="9b60647a-c825-4266-aafa-670849c64782" providerId="ADAL" clId="{292526B5-234E-5EAA-AFB8-0412B8CA4453}" dt="2025-10-07T13:25:14.190" v="4" actId="20577"/>
+          <ac:chgData name="Andrew Turner" userId="9b60647a-c825-4266-aafa-670849c64782" providerId="ADAL" clId="{292526B5-234E-5EAA-AFB8-0412B8CA4453}" dt="2026-02-25T20:23:15.009" v="24" actId="20577"/>
           <ac:spMkLst>
             <pc:docMk/>
-            <pc:sldMk cId="3776241177" sldId="264"/>
-            <ac:spMk id="3" creationId="{EE2F3B10-AFB1-73CD-83F6-060F12D1E286}"/>
+            <pc:sldMk cId="3766210556" sldId="259"/>
+            <ac:spMk id="3" creationId="{9A59D3BF-56DD-6729-C183-BDA08118E1EE}"/>
           </ac:spMkLst>
         </pc:spChg>
       </pc:sldChg>
-      <pc:sldChg chg="modSp new del mod">
-        <pc:chgData name="Andrew Turner" userId="9b60647a-c825-4266-aafa-670849c64782" providerId="ADAL" clId="{292526B5-234E-5EAA-AFB8-0412B8CA4453}" dt="2025-10-07T13:25:40.559" v="16" actId="2696"/>
-        <pc:sldMkLst>
-          <pc:docMk/>
-          <pc:sldMk cId="314497227" sldId="266"/>
-        </pc:sldMkLst>
-        <pc:spChg chg="mod">
-          <ac:chgData name="Andrew Turner" userId="9b60647a-c825-4266-aafa-670849c64782" providerId="ADAL" clId="{292526B5-234E-5EAA-AFB8-0412B8CA4453}" dt="2025-10-07T13:25:26.694" v="14" actId="20577"/>
-          <ac:spMkLst>
-            <pc:docMk/>
-            <pc:sldMk cId="314497227" sldId="266"/>
-            <ac:spMk id="2" creationId="{0B97F9A2-A236-9732-60E8-7A9E20F061A2}"/>
-          </ac:spMkLst>
-        </pc:spChg>
-      </pc:sldChg>
-      <pc:sldChg chg="modSp add">
-        <pc:chgData name="Andrew Turner" userId="9b60647a-c825-4266-aafa-670849c64782" providerId="ADAL" clId="{292526B5-234E-5EAA-AFB8-0412B8CA4453}" dt="2025-10-07T13:26:08.002" v="19"/>
-        <pc:sldMkLst>
-          <pc:docMk/>
-          <pc:sldMk cId="1126882526" sldId="1685"/>
-        </pc:sldMkLst>
-        <pc:spChg chg="mod">
-          <ac:chgData name="Andrew Turner" userId="9b60647a-c825-4266-aafa-670849c64782" providerId="ADAL" clId="{292526B5-234E-5EAA-AFB8-0412B8CA4453}" dt="2025-10-07T13:25:50.439" v="17"/>
-          <ac:spMkLst>
-            <pc:docMk/>
-            <pc:sldMk cId="1126882526" sldId="1685"/>
-            <ac:spMk id="3" creationId="{A0E92289-F23D-47E6-6305-4F71A4F96F62}"/>
-          </ac:spMkLst>
-        </pc:spChg>
-        <pc:spChg chg="mod">
-          <ac:chgData name="Andrew Turner" userId="9b60647a-c825-4266-aafa-670849c64782" providerId="ADAL" clId="{292526B5-234E-5EAA-AFB8-0412B8CA4453}" dt="2025-10-07T13:26:08.002" v="19"/>
-          <ac:spMkLst>
-            <pc:docMk/>
-            <pc:sldMk cId="1126882526" sldId="1685"/>
-            <ac:spMk id="5" creationId="{11954015-84E1-79C2-6144-FE69DA6CBB83}"/>
-          </ac:spMkLst>
-        </pc:spChg>
-      </pc:sldChg>
-      <pc:sldMasterChg chg="setBg modSldLayout">
-        <pc:chgData name="Andrew Turner" userId="9b60647a-c825-4266-aafa-670849c64782" providerId="ADAL" clId="{292526B5-234E-5EAA-AFB8-0412B8CA4453}" dt="2025-10-07T13:25:00.156" v="1"/>
-        <pc:sldMasterMkLst>
-          <pc:docMk/>
-          <pc:sldMasterMk cId="3036371404" sldId="2147483648"/>
-        </pc:sldMasterMkLst>
-        <pc:sldLayoutChg chg="setBg">
-          <pc:chgData name="Andrew Turner" userId="9b60647a-c825-4266-aafa-670849c64782" providerId="ADAL" clId="{292526B5-234E-5EAA-AFB8-0412B8CA4453}" dt="2025-10-07T13:25:00.156" v="1"/>
-          <pc:sldLayoutMkLst>
-            <pc:docMk/>
-            <pc:sldMasterMk cId="3036371404" sldId="2147483648"/>
-            <pc:sldLayoutMk cId="1482963963" sldId="2147483649"/>
-          </pc:sldLayoutMkLst>
-        </pc:sldLayoutChg>
-        <pc:sldLayoutChg chg="setBg">
-          <pc:chgData name="Andrew Turner" userId="9b60647a-c825-4266-aafa-670849c64782" providerId="ADAL" clId="{292526B5-234E-5EAA-AFB8-0412B8CA4453}" dt="2025-10-07T13:25:00.156" v="1"/>
-          <pc:sldLayoutMkLst>
-            <pc:docMk/>
-            <pc:sldMasterMk cId="3036371404" sldId="2147483648"/>
-            <pc:sldLayoutMk cId="1438169853" sldId="2147483650"/>
-          </pc:sldLayoutMkLst>
-        </pc:sldLayoutChg>
-        <pc:sldLayoutChg chg="setBg">
-          <pc:chgData name="Andrew Turner" userId="9b60647a-c825-4266-aafa-670849c64782" providerId="ADAL" clId="{292526B5-234E-5EAA-AFB8-0412B8CA4453}" dt="2025-10-07T13:25:00.156" v="1"/>
-          <pc:sldLayoutMkLst>
-            <pc:docMk/>
-            <pc:sldMasterMk cId="3036371404" sldId="2147483648"/>
-            <pc:sldLayoutMk cId="1966295484" sldId="2147483651"/>
-          </pc:sldLayoutMkLst>
-        </pc:sldLayoutChg>
-        <pc:sldLayoutChg chg="setBg">
-          <pc:chgData name="Andrew Turner" userId="9b60647a-c825-4266-aafa-670849c64782" providerId="ADAL" clId="{292526B5-234E-5EAA-AFB8-0412B8CA4453}" dt="2025-10-07T13:25:00.156" v="1"/>
-          <pc:sldLayoutMkLst>
-            <pc:docMk/>
-            <pc:sldMasterMk cId="3036371404" sldId="2147483648"/>
-            <pc:sldLayoutMk cId="985777094" sldId="2147483652"/>
-          </pc:sldLayoutMkLst>
-        </pc:sldLayoutChg>
-        <pc:sldLayoutChg chg="setBg">
-          <pc:chgData name="Andrew Turner" userId="9b60647a-c825-4266-aafa-670849c64782" providerId="ADAL" clId="{292526B5-234E-5EAA-AFB8-0412B8CA4453}" dt="2025-10-07T13:25:00.156" v="1"/>
-          <pc:sldLayoutMkLst>
-            <pc:docMk/>
-            <pc:sldMasterMk cId="3036371404" sldId="2147483648"/>
-            <pc:sldLayoutMk cId="811048285" sldId="2147483653"/>
-          </pc:sldLayoutMkLst>
-        </pc:sldLayoutChg>
-        <pc:sldLayoutChg chg="setBg">
-          <pc:chgData name="Andrew Turner" userId="9b60647a-c825-4266-aafa-670849c64782" providerId="ADAL" clId="{292526B5-234E-5EAA-AFB8-0412B8CA4453}" dt="2025-10-07T13:25:00.156" v="1"/>
-          <pc:sldLayoutMkLst>
-            <pc:docMk/>
-            <pc:sldMasterMk cId="3036371404" sldId="2147483648"/>
-            <pc:sldLayoutMk cId="2715104060" sldId="2147483654"/>
-          </pc:sldLayoutMkLst>
-        </pc:sldLayoutChg>
-        <pc:sldLayoutChg chg="setBg">
-          <pc:chgData name="Andrew Turner" userId="9b60647a-c825-4266-aafa-670849c64782" providerId="ADAL" clId="{292526B5-234E-5EAA-AFB8-0412B8CA4453}" dt="2025-10-07T13:25:00.156" v="1"/>
-          <pc:sldLayoutMkLst>
-            <pc:docMk/>
-            <pc:sldMasterMk cId="3036371404" sldId="2147483648"/>
-            <pc:sldLayoutMk cId="1034652476" sldId="2147483655"/>
-          </pc:sldLayoutMkLst>
-        </pc:sldLayoutChg>
-        <pc:sldLayoutChg chg="setBg">
-          <pc:chgData name="Andrew Turner" userId="9b60647a-c825-4266-aafa-670849c64782" providerId="ADAL" clId="{292526B5-234E-5EAA-AFB8-0412B8CA4453}" dt="2025-10-07T13:25:00.156" v="1"/>
-          <pc:sldLayoutMkLst>
-            <pc:docMk/>
-            <pc:sldMasterMk cId="3036371404" sldId="2147483648"/>
-            <pc:sldLayoutMk cId="1288493758" sldId="2147483656"/>
-          </pc:sldLayoutMkLst>
-        </pc:sldLayoutChg>
-        <pc:sldLayoutChg chg="setBg">
-          <pc:chgData name="Andrew Turner" userId="9b60647a-c825-4266-aafa-670849c64782" providerId="ADAL" clId="{292526B5-234E-5EAA-AFB8-0412B8CA4453}" dt="2025-10-07T13:25:00.156" v="1"/>
-          <pc:sldLayoutMkLst>
-            <pc:docMk/>
-            <pc:sldMasterMk cId="3036371404" sldId="2147483648"/>
-            <pc:sldLayoutMk cId="389398052" sldId="2147483657"/>
-          </pc:sldLayoutMkLst>
-        </pc:sldLayoutChg>
-        <pc:sldLayoutChg chg="setBg">
-          <pc:chgData name="Andrew Turner" userId="9b60647a-c825-4266-aafa-670849c64782" providerId="ADAL" clId="{292526B5-234E-5EAA-AFB8-0412B8CA4453}" dt="2025-10-07T13:25:00.156" v="1"/>
-          <pc:sldLayoutMkLst>
-            <pc:docMk/>
-            <pc:sldMasterMk cId="3036371404" sldId="2147483648"/>
-            <pc:sldLayoutMk cId="2031966020" sldId="2147483658"/>
-          </pc:sldLayoutMkLst>
-        </pc:sldLayoutChg>
-        <pc:sldLayoutChg chg="setBg">
-          <pc:chgData name="Andrew Turner" userId="9b60647a-c825-4266-aafa-670849c64782" providerId="ADAL" clId="{292526B5-234E-5EAA-AFB8-0412B8CA4453}" dt="2025-10-07T13:25:00.156" v="1"/>
-          <pc:sldLayoutMkLst>
-            <pc:docMk/>
-            <pc:sldMasterMk cId="3036371404" sldId="2147483648"/>
-            <pc:sldLayoutMk cId="2274238804" sldId="2147483659"/>
-          </pc:sldLayoutMkLst>
-        </pc:sldLayoutChg>
-      </pc:sldMasterChg>
     </pc:docChg>
   </pc:docChgLst>
 </pc:chgInfo>
@@ -446,7 +306,7 @@
           <a:p>
             <a:fld id="{76EE0887-D5C2-2A4F-BDDA-31544A802108}" type="datetimeFigureOut">
               <a:rPr lang="en-GB" smtClean="0"/>
-              <a:t>07/10/2025</a:t>
+              <a:t>25/02/2026</a:t>
             </a:fld>
             <a:endParaRPr lang="en-GB"/>
           </a:p>
@@ -644,7 +504,7 @@
           <a:p>
             <a:fld id="{76EE0887-D5C2-2A4F-BDDA-31544A802108}" type="datetimeFigureOut">
               <a:rPr lang="en-GB" smtClean="0"/>
-              <a:t>07/10/2025</a:t>
+              <a:t>25/02/2026</a:t>
             </a:fld>
             <a:endParaRPr lang="en-GB"/>
           </a:p>
@@ -852,7 +712,7 @@
           <a:p>
             <a:fld id="{76EE0887-D5C2-2A4F-BDDA-31544A802108}" type="datetimeFigureOut">
               <a:rPr lang="en-GB" smtClean="0"/>
-              <a:t>07/10/2025</a:t>
+              <a:t>25/02/2026</a:t>
             </a:fld>
             <a:endParaRPr lang="en-GB"/>
           </a:p>
@@ -1050,7 +910,7 @@
           <a:p>
             <a:fld id="{76EE0887-D5C2-2A4F-BDDA-31544A802108}" type="datetimeFigureOut">
               <a:rPr lang="en-GB" smtClean="0"/>
-              <a:t>07/10/2025</a:t>
+              <a:t>25/02/2026</a:t>
             </a:fld>
             <a:endParaRPr lang="en-GB"/>
           </a:p>
@@ -1325,7 +1185,7 @@
           <a:p>
             <a:fld id="{76EE0887-D5C2-2A4F-BDDA-31544A802108}" type="datetimeFigureOut">
               <a:rPr lang="en-GB" smtClean="0"/>
-              <a:t>07/10/2025</a:t>
+              <a:t>25/02/2026</a:t>
             </a:fld>
             <a:endParaRPr lang="en-GB"/>
           </a:p>
@@ -1590,7 +1450,7 @@
           <a:p>
             <a:fld id="{76EE0887-D5C2-2A4F-BDDA-31544A802108}" type="datetimeFigureOut">
               <a:rPr lang="en-GB" smtClean="0"/>
-              <a:t>07/10/2025</a:t>
+              <a:t>25/02/2026</a:t>
             </a:fld>
             <a:endParaRPr lang="en-GB"/>
           </a:p>
@@ -2002,7 +1862,7 @@
           <a:p>
             <a:fld id="{76EE0887-D5C2-2A4F-BDDA-31544A802108}" type="datetimeFigureOut">
               <a:rPr lang="en-GB" smtClean="0"/>
-              <a:t>07/10/2025</a:t>
+              <a:t>25/02/2026</a:t>
             </a:fld>
             <a:endParaRPr lang="en-GB"/>
           </a:p>
@@ -2143,7 +2003,7 @@
           <a:p>
             <a:fld id="{76EE0887-D5C2-2A4F-BDDA-31544A802108}" type="datetimeFigureOut">
               <a:rPr lang="en-GB" smtClean="0"/>
-              <a:t>07/10/2025</a:t>
+              <a:t>25/02/2026</a:t>
             </a:fld>
             <a:endParaRPr lang="en-GB"/>
           </a:p>
@@ -2256,7 +2116,7 @@
           <a:p>
             <a:fld id="{76EE0887-D5C2-2A4F-BDDA-31544A802108}" type="datetimeFigureOut">
               <a:rPr lang="en-GB" smtClean="0"/>
-              <a:t>07/10/2025</a:t>
+              <a:t>25/02/2026</a:t>
             </a:fld>
             <a:endParaRPr lang="en-GB"/>
           </a:p>
@@ -2567,7 +2427,7 @@
           <a:p>
             <a:fld id="{76EE0887-D5C2-2A4F-BDDA-31544A802108}" type="datetimeFigureOut">
               <a:rPr lang="en-GB" smtClean="0"/>
-              <a:t>07/10/2025</a:t>
+              <a:t>25/02/2026</a:t>
             </a:fld>
             <a:endParaRPr lang="en-GB"/>
           </a:p>
@@ -2855,7 +2715,7 @@
           <a:p>
             <a:fld id="{76EE0887-D5C2-2A4F-BDDA-31544A802108}" type="datetimeFigureOut">
               <a:rPr lang="en-GB" smtClean="0"/>
-              <a:t>07/10/2025</a:t>
+              <a:t>25/02/2026</a:t>
             </a:fld>
             <a:endParaRPr lang="en-GB"/>
           </a:p>
@@ -3099,7 +2959,7 @@
           <a:p>
             <a:fld id="{76EE0887-D5C2-2A4F-BDDA-31544A802108}" type="datetimeFigureOut">
               <a:rPr lang="en-GB" smtClean="0"/>
-              <a:t>07/10/2025</a:t>
+              <a:t>25/02/2026</a:t>
             </a:fld>
             <a:endParaRPr lang="en-GB"/>
           </a:p>
@@ -4790,10 +4650,7 @@
               </a:rPr>
               <a:t>the waste energy of the LUMI supercomputer is used to heat a city</a:t>
             </a:r>
-            <a:r>
-              <a:rPr lang="en-GB" dirty="0"/>
-              <a:t>;</a:t>
-            </a:r>
+            <a:endParaRPr lang="en-GB" dirty="0"/>
           </a:p>
           <a:p>
             <a:r>
@@ -4804,9 +4661,16 @@
           <a:p>
             <a:pPr lvl="1"/>
             <a:r>
-              <a:rPr lang="en-GB" dirty="0"/>
-              <a:t>https://www.archer2.ac.uk/community/sustainability/</a:t>
-            </a:r>
+              <a:rPr lang="en-GB" dirty="0">
+                <a:hlinkClick r:id="rId3"/>
+              </a:rPr>
+              <a:t>Improving the sustainability of the ARCHER2 supercomputing service</a:t>
+            </a:r>
+            <a:endParaRPr lang="en-GB" dirty="0"/>
+          </a:p>
+          <a:p>
+            <a:pPr lvl="1"/>
+            <a:endParaRPr lang="en-GB" dirty="0"/>
           </a:p>
         </p:txBody>
       </p:sp>

</xml_diff>